<commit_message>
Add published notebook journey evidence
</commit_message>
<xml_diff>
--- a/prototype/eligibility-workspace/qa/evidence/notebook-approved-journey/Help-Eligibility-Workers-Explain-Verify-And-Document-presentation.pptx
+++ b/prototype/eligibility-workspace/qa/evidence/notebook-approved-journey/Help-Eligibility-Workers-Explain-Verify-And-Document-presentation.pptx
@@ -10,9 +10,10 @@
     <p:sldId id="258" r:id="rId4"/>
     <p:sldId id="259" r:id="rId5"/>
     <p:sldId id="260" r:id="rId6"/>
+    <p:sldId id="261" r:id="rId7"/>
   </p:sldIdLst>
   <p:notesMasterIdLst>
-    <p:notesMasterId r:id="rId7"/>
+    <p:notesMasterId r:id="rId8"/>
   </p:notesMasterIdLst>
   <p:sldSz cx="12192000" cy="6858000"/>
   <p:notesSz cx="6858000" cy="12192000"/>
@@ -682,7 +683,7 @@
           <a:p>
             <a:r>
               <a:rPr lang="en-US" dirty="0"/>
-              <a:t>When electronic data is incomplete, request acceptable proof and explain the available options in plain language.</a:t>
+              <a:t>When electronic data is incomplete, eligibility workers should request acceptable proof and explain available options clearly.</a:t>
             </a:r>
             <a:endParaRPr lang="en-US" dirty="0"/>
           </a:p>
@@ -770,7 +771,7 @@
           <a:p>
             <a:r>
               <a:rPr lang="en-US" dirty="0"/>
-              <a:t>Program-specific reporting requirements must remain explicit and should not be combined into a universal rule.</a:t>
+              <a:t>Program-specific reporting requirements must be explicit, without combining different deadlines into a universal rule.</a:t>
             </a:r>
             <a:endParaRPr lang="en-US" dirty="0"/>
           </a:p>
@@ -858,7 +859,7 @@
           <a:p>
             <a:r>
               <a:rPr lang="en-US" dirty="0"/>
-              <a:t>Workers should confirm the reported change, identify the affected program, request required evidence, document the action, and inform the household of the next step.</a:t>
+              <a:t>Eligibility workers need to confirm reported changes, identify the affected program, request necessary evidence, document the action taken, and inform the household of the next steps.</a:t>
             </a:r>
             <a:endParaRPr lang="en-US" dirty="0"/>
           </a:p>
@@ -882,6 +883,94 @@
             <a:fld id="{F7021451-1387-4CA6-816F-3879F97B5CBC}" type="slidenum">
               <a:rPr lang="en-US"/>
               <a:t>5</a:t>
+            </a:fld>
+            <a:endParaRPr lang="en-US"/>
+          </a:p>
+        </p:txBody>
+      </p:sp>
+    </p:spTree>
+    <p:extLst>
+      <p:ext uri="{BB962C8B-B14F-4D97-AF65-F5344CB8AC3E}">
+        <p14:creationId xmlns:p14="http://schemas.microsoft.com/office/powerpoint/2010/main" val="1024086991"/>
+      </p:ext>
+    </p:extLst>
+  </p:cSld>
+  <p:clrMapOvr>
+    <a:masterClrMapping/>
+  </p:clrMapOvr>
+</p:notes>
+</file>
+
+<file path=ppt/notesSlides/notesSlide6.xml><?xml version="1.0" encoding="utf-8"?>
+<p:notes xmlns:a="http://schemas.openxmlformats.org/drawingml/2006/main" xmlns:r="http://schemas.openxmlformats.org/officeDocument/2006/relationships" xmlns:p="http://schemas.openxmlformats.org/presentationml/2006/main">
+  <p:cSld>
+    <p:spTree>
+      <p:nvGrpSpPr>
+        <p:cNvPr id="1" name=""/>
+        <p:cNvGrpSpPr/>
+        <p:nvPr/>
+      </p:nvGrpSpPr>
+      <p:grpSpPr>
+        <a:xfrm>
+          <a:off x="0" y="0"/>
+          <a:ext cx="0" cy="0"/>
+          <a:chOff x="0" y="0"/>
+          <a:chExt cx="0" cy="0"/>
+        </a:xfrm>
+      </p:grpSpPr>
+      <p:sp>
+        <p:nvSpPr>
+          <p:cNvPr id="2" name="Slide Image Placeholder 1"/>
+          <p:cNvSpPr>
+            <a:spLocks noGrp="1" noRot="1" noChangeAspect="1"/>
+          </p:cNvSpPr>
+          <p:nvPr>
+            <p:ph type="sldImg"/>
+          </p:nvPr>
+        </p:nvSpPr>
+        <p:spPr/>
+      </p:sp>
+      <p:sp>
+        <p:nvSpPr>
+          <p:cNvPr id="3" name="Notes Placeholder 2"/>
+          <p:cNvSpPr>
+            <a:spLocks noGrp="1"/>
+          </p:cNvSpPr>
+          <p:nvPr>
+            <p:ph type="body" idx="1"/>
+          </p:nvPr>
+        </p:nvSpPr>
+        <p:spPr/>
+        <p:txBody>
+          <a:bodyPr/>
+          <a:lstStyle/>
+          <a:p>
+            <a:r>
+              <a:rPr lang="en-US" dirty="0"/>
+              <a:t>Eligibility workers must thoroughly document all aspects of a reported change to ensure compliance and accurate record-keeping.</a:t>
+            </a:r>
+            <a:endParaRPr lang="en-US" dirty="0"/>
+          </a:p>
+        </p:txBody>
+      </p:sp>
+      <p:sp>
+        <p:nvSpPr>
+          <p:cNvPr id="4" name="Slide Number Placeholder 3"/>
+          <p:cNvSpPr>
+            <a:spLocks noGrp="1"/>
+          </p:cNvSpPr>
+          <p:nvPr>
+            <p:ph type="sldNum" sz="quarter" idx="10"/>
+          </p:nvPr>
+        </p:nvSpPr>
+        <p:spPr/>
+        <p:txBody>
+          <a:bodyPr/>
+          <a:lstStyle/>
+          <a:p>
+            <a:fld id="{F7021451-1387-4CA6-816F-3879F97B5CBC}" type="slidenum">
+              <a:rPr lang="en-US"/>
+              <a:t>6</a:t>
             </a:fld>
             <a:endParaRPr lang="en-US"/>
           </a:p>
@@ -1301,7 +1390,7 @@
         <p:spPr>
           <a:xfrm>
             <a:off x="594360" y="1965960"/>
-            <a:ext cx="10607040" cy="1280160"/>
+            <a:ext cx="5760720" cy="1280160"/>
           </a:xfrm>
           <a:prstGeom prst="rect">
             <a:avLst/>
@@ -1337,7 +1426,7 @@
         <p:spPr>
           <a:xfrm>
             <a:off x="594360" y="3337560"/>
-            <a:ext cx="10424160" cy="1965960"/>
+            <a:ext cx="5669280" cy="1965960"/>
           </a:xfrm>
           <a:prstGeom prst="rect">
             <a:avLst/>
@@ -1364,9 +1453,33 @@
           </a:p>
         </p:txBody>
       </p:sp>
-      <p:sp>
-        <p:nvSpPr>
-          <p:cNvPr id="6" name="Text 4"/>
+      <p:pic>
+        <p:nvPicPr>
+          <p:cNvPr id="6" name="Image 0" descr="preencoded.png">    </p:cNvPr>
+          <p:cNvPicPr>
+            <a:picLocks noChangeAspect="1"/>
+          </p:cNvPicPr>
+          <p:nvPr/>
+        </p:nvPicPr>
+        <p:blipFill>
+          <a:blip r:embed="rId1"/>
+          <a:stretch>
+            <a:fillRect/>
+          </a:stretch>
+        </p:blipFill>
+        <p:spPr>
+          <a:xfrm>
+            <a:off x="6995160" y="640080"/>
+            <a:ext cx="4663440" cy="5577840"/>
+          </a:xfrm>
+          <a:prstGeom prst="rect">
+            <a:avLst/>
+          </a:prstGeom>
+        </p:spPr>
+      </p:pic>
+      <p:sp>
+        <p:nvSpPr>
+          <p:cNvPr id="7" name="Text 4"/>
           <p:cNvSpPr/>
           <p:nvPr/>
         </p:nvSpPr>
@@ -1760,7 +1873,7 @@
                   <a:srgbClr val="52666D"/>
                 </a:solidFill>
               </a:rPr>
-              <a:t>When electronic data is incomplete, request acceptable proof and explain the available options in plain language.</a:t>
+              <a:t>When electronic data is incomplete, eligibility workers should request acceptable proof and explain available options clearly.</a:t>
             </a:r>
             <a:endParaRPr lang="en-US" sz="1500" dirty="0"/>
           </a:p>
@@ -1961,7 +2074,7 @@
                   <a:srgbClr val="52666D"/>
                 </a:solidFill>
               </a:rPr>
-              <a:t>Program-specific reporting requirements must remain explicit and should not be combined into a universal rule.</a:t>
+              <a:t>Program-specific reporting requirements must be explicit, without combining different deadlines into a universal rule.</a:t>
             </a:r>
             <a:endParaRPr lang="en-US" sz="1500" dirty="0"/>
           </a:p>
@@ -2162,7 +2275,7 @@
                   <a:srgbClr val="52666D"/>
                 </a:solidFill>
               </a:rPr>
-              <a:t>Workers should confirm the reported change, identify the affected program, request required evidence, document the action, and inform the household of the next step.</a:t>
+              <a:t>Eligibility workers need to confirm reported changes, identify the affected program, request necessary evidence, document the action taken, and inform the household of the next steps.</a:t>
             </a:r>
             <a:endParaRPr lang="en-US" sz="1500" dirty="0"/>
           </a:p>
@@ -2199,6 +2312,207 @@
                 </a:solidFill>
               </a:rPr>
               <a:t>5  ·  Brief v1</a:t>
+            </a:r>
+            <a:endParaRPr lang="en-US" sz="800" dirty="0"/>
+          </a:p>
+        </p:txBody>
+      </p:sp>
+    </p:spTree>
+  </p:cSld>
+  <p:clrMapOvr>
+    <a:masterClrMapping/>
+  </p:clrMapOvr>
+</p:sld>
+</file>
+
+<file path=ppt/slides/slide6.xml><?xml version="1.0" encoding="utf-8"?>
+<p:sld xmlns:a="http://schemas.openxmlformats.org/drawingml/2006/main" xmlns:r="http://schemas.openxmlformats.org/officeDocument/2006/relationships" xmlns:p="http://schemas.openxmlformats.org/presentationml/2006/main">
+  <p:cSld name="Slide 6">
+    <p:bg>
+      <p:bgPr>
+        <a:solidFill>
+          <a:srgbClr val="F4F7F7"/>
+        </a:solidFill>
+      </p:bgPr>
+    </p:bg>
+    <p:spTree>
+      <p:nvGrpSpPr>
+        <p:cNvPr id="1" name=""/>
+        <p:cNvGrpSpPr/>
+        <p:nvPr/>
+      </p:nvGrpSpPr>
+      <p:grpSpPr>
+        <a:xfrm>
+          <a:off x="0" y="0"/>
+          <a:ext cx="0" cy="0"/>
+          <a:chOff x="0" y="0"/>
+          <a:chExt cx="0" cy="0"/>
+        </a:xfrm>
+      </p:grpSpPr>
+      <p:sp>
+        <p:nvSpPr>
+          <p:cNvPr id="2" name="Shape 0"/>
+          <p:cNvSpPr/>
+          <p:nvPr/>
+        </p:nvSpPr>
+        <p:spPr>
+          <a:xfrm>
+            <a:off x="0" y="0"/>
+            <a:ext cx="109728" cy="6858000"/>
+          </a:xfrm>
+          <a:prstGeom prst="rect">
+            <a:avLst/>
+          </a:prstGeom>
+          <a:solidFill>
+            <a:srgbClr val="FF5D27"/>
+          </a:solidFill>
+          <a:ln w="12700">
+            <a:solidFill>
+              <a:srgbClr val="FF5D27"/>
+            </a:solidFill>
+            <a:prstDash val="solid"/>
+          </a:ln>
+        </p:spPr>
+      </p:sp>
+      <p:sp>
+        <p:nvSpPr>
+          <p:cNvPr id="3" name="Text 1"/>
+          <p:cNvSpPr/>
+          <p:nvPr/>
+        </p:nvSpPr>
+        <p:spPr>
+          <a:xfrm>
+            <a:off x="502920" y="329184"/>
+            <a:ext cx="1828800" cy="274320"/>
+          </a:xfrm>
+          <a:prstGeom prst="rect">
+            <a:avLst/>
+          </a:prstGeom>
+          <a:noFill/>
+          <a:ln/>
+        </p:spPr>
+        <p:txBody>
+          <a:bodyPr wrap="square" lIns="0" tIns="0" rIns="0" bIns="0" rtlCol="0" anchor="ctr"/>
+          <a:lstStyle/>
+          <a:p>
+            <a:pPr indent="0" marL="0">
+              <a:buNone/>
+            </a:pPr>
+            <a:r>
+              <a:rPr lang="en-US" sz="900" b="1" spc="160" kern="0" dirty="0">
+                <a:solidFill>
+                  <a:srgbClr val="385F68"/>
+                </a:solidFill>
+              </a:rPr>
+              <a:t>BLUEORIGIN</a:t>
+            </a:r>
+            <a:endParaRPr lang="en-US" sz="900" dirty="0"/>
+          </a:p>
+        </p:txBody>
+      </p:sp>
+      <p:sp>
+        <p:nvSpPr>
+          <p:cNvPr id="4" name="Text 2"/>
+          <p:cNvSpPr/>
+          <p:nvPr/>
+        </p:nvSpPr>
+        <p:spPr>
+          <a:xfrm>
+            <a:off x="594360" y="960120"/>
+            <a:ext cx="10607040" cy="1280160"/>
+          </a:xfrm>
+          <a:prstGeom prst="rect">
+            <a:avLst/>
+          </a:prstGeom>
+          <a:noFill/>
+          <a:ln/>
+        </p:spPr>
+        <p:txBody>
+          <a:bodyPr wrap="square" lIns="0" tIns="0" rIns="0" bIns="0" rtlCol="0" anchor="ctr"/>
+          <a:lstStyle/>
+          <a:p>
+            <a:pPr indent="0" marL="0">
+              <a:buNone/>
+            </a:pPr>
+            <a:r>
+              <a:rPr lang="en-US" sz="2500" b="1" dirty="0">
+                <a:solidFill>
+                  <a:srgbClr val="17343C"/>
+                </a:solidFill>
+              </a:rPr>
+              <a:t>Documentation</a:t>
+            </a:r>
+            <a:endParaRPr lang="en-US" sz="2500" dirty="0"/>
+          </a:p>
+        </p:txBody>
+      </p:sp>
+      <p:sp>
+        <p:nvSpPr>
+          <p:cNvPr id="5" name="Text 3"/>
+          <p:cNvSpPr/>
+          <p:nvPr/>
+        </p:nvSpPr>
+        <p:spPr>
+          <a:xfrm>
+            <a:off x="594360" y="2423160"/>
+            <a:ext cx="10424160" cy="1965960"/>
+          </a:xfrm>
+          <a:prstGeom prst="rect">
+            <a:avLst/>
+          </a:prstGeom>
+          <a:noFill/>
+          <a:ln/>
+        </p:spPr>
+        <p:txBody>
+          <a:bodyPr wrap="square" lIns="0" tIns="0" rIns="0" bIns="0" rtlCol="0" anchor="t"/>
+          <a:lstStyle/>
+          <a:p>
+            <a:pPr indent="0" marL="0">
+              <a:buNone/>
+            </a:pPr>
+            <a:r>
+              <a:rPr lang="en-US" sz="1500" dirty="0">
+                <a:solidFill>
+                  <a:srgbClr val="52666D"/>
+                </a:solidFill>
+              </a:rPr>
+              <a:t>Eligibility workers must thoroughly document all aspects of a reported change to ensure compliance and accurate record-keeping.</a:t>
+            </a:r>
+            <a:endParaRPr lang="en-US" sz="1500" dirty="0"/>
+          </a:p>
+        </p:txBody>
+      </p:sp>
+      <p:sp>
+        <p:nvSpPr>
+          <p:cNvPr id="6" name="Text 4"/>
+          <p:cNvSpPr/>
+          <p:nvPr/>
+        </p:nvSpPr>
+        <p:spPr>
+          <a:xfrm>
+            <a:off x="594360" y="6455664"/>
+            <a:ext cx="2743200" cy="182880"/>
+          </a:xfrm>
+          <a:prstGeom prst="rect">
+            <a:avLst/>
+          </a:prstGeom>
+          <a:noFill/>
+          <a:ln/>
+        </p:spPr>
+        <p:txBody>
+          <a:bodyPr wrap="square" lIns="0" tIns="0" rIns="0" bIns="0" rtlCol="0" anchor="ctr"/>
+          <a:lstStyle/>
+          <a:p>
+            <a:pPr indent="0" marL="0">
+              <a:buNone/>
+            </a:pPr>
+            <a:r>
+              <a:rPr lang="en-US" sz="800" dirty="0">
+                <a:solidFill>
+                  <a:srgbClr val="6D7B80"/>
+                </a:solidFill>
+              </a:rPr>
+              <a:t>6  ·  Brief v1</a:t>
             </a:r>
             <a:endParaRPr lang="en-US" sz="800" dirty="0"/>
           </a:p>

</xml_diff>